<commit_message>
Progress deck: American spelling on the two slides that had it
memorisation on the stability slide and generalised in the Stage 3 bullet.

Co-Authored-By: Claude Opus 5 <noreply@anthropic.com>
Claude-Session: https://claude.ai/code/session_01A54DUp2K2ADqzEJ7zvsPHg
</commit_message>
<xml_diff>
--- a/docs/notes/Slides/Mina_Progress_Slides_2026-10-22.pptx
+++ b/docs/notes/Slides/Mina_Progress_Slides_2026-10-22.pptx
@@ -4863,7 +4863,7 @@
                   <a:srgbClr val="615D59"/>
                 </a:solidFill>
               </a:rPr>
-              <a:t> IsoFormer's aggregator with memory-safe batching; the grid generalised so any Stage 1 encoder but DNABERT-2 can take any slot.</a:t>
+              <a:t> IsoFormer's aggregator with memory-safe batching; the grid generalized so any Stage 1 encoder but DNABERT-2 can take any slot.</a:t>
             </a:r>
             <a:endParaRPr lang="en-US" sz="1250" dirty="0"/>
           </a:p>
@@ -13171,7 +13171,7 @@
                   <a:schemeClr val="tx1"/>
                 </a:solidFill>
               </a:rPr>
-              <a:t>The published stability split is mostly memorisation: every model drops 0.2 on unseen sequences</a:t>
+              <a:t>The published stability split is mostly memorization: every model drops 0.2 on unseen sequences</a:t>
             </a:r>
             <a:endParaRPr lang="en-US" sz="2500" dirty="0"/>
           </a:p>

</xml_diff>